<commit_message>
fixed bug with calculated aspect ratio always being landscape
</commit_message>
<xml_diff>
--- a/src/processing/export/reference.pptx
+++ b/src/processing/export/reference.pptx
@@ -1223,8 +1223,8 @@
         </p:nvSpPr>
         <p:spPr>
           <a:xfrm>
-            <a:off x="1130300" y="1803400"/>
-            <a:ext cx="5825202" cy="1234727"/>
+            <a:off x="746717" y="1056097"/>
+            <a:ext cx="6694815" cy="1564259"/>
           </a:xfrm>
         </p:spPr>
         <p:txBody>
@@ -1232,7 +1232,7 @@
             <a:noAutofit/>
           </a:bodyPr>
           <a:lstStyle>
-            <a:lvl1pPr algn="r">
+            <a:lvl1pPr algn="ctr">
               <a:defRPr sz="3600">
                 <a:solidFill>
                   <a:schemeClr val="accent1"/>
@@ -1260,14 +1260,14 @@
         </p:nvSpPr>
         <p:spPr>
           <a:xfrm>
-            <a:off x="1130300" y="3038125"/>
+            <a:off x="1130300" y="2973510"/>
             <a:ext cx="5825202" cy="822674"/>
           </a:xfrm>
         </p:spPr>
         <p:txBody>
           <a:bodyPr anchor="t"/>
           <a:lstStyle>
-            <a:lvl1pPr marL="0" indent="0" algn="r">
+            <a:lvl1pPr marL="0" indent="0" algn="ctr">
               <a:buNone/>
               <a:defRPr>
                 <a:solidFill>
@@ -1361,10 +1361,9 @@
           </a:lstStyle>
           <a:p>
             <a:r>
-              <a:rPr lang="en-US"/>
+              <a:rPr lang="en-US" dirty="0"/>
               <a:t>Click to edit Master subtitle style</a:t>
             </a:r>
-            <a:endParaRPr lang="en-US" dirty="0"/>
           </a:p>
         </p:txBody>
       </p:sp>
@@ -5846,8 +5845,8 @@
         </p:nvSpPr>
         <p:spPr>
           <a:xfrm>
-            <a:off x="508001" y="457200"/>
-            <a:ext cx="7384715" cy="469232"/>
+            <a:off x="78205" y="457200"/>
+            <a:ext cx="8386011" cy="469232"/>
           </a:xfrm>
           <a:prstGeom prst="rect">
             <a:avLst/>
@@ -6074,7 +6073,7 @@
   <p:hf hdr="0" ftr="0" dt="0"/>
   <p:txStyles>
     <p:titleStyle>
-      <a:lvl1pPr algn="l" defTabSz="342900" rtl="0" eaLnBrk="1" latinLnBrk="0" hangingPunct="1">
+      <a:lvl1pPr algn="ctr" defTabSz="342900" rtl="0" eaLnBrk="1" latinLnBrk="0" hangingPunct="1">
         <a:spcBef>
           <a:spcPct val="0"/>
         </a:spcBef>
@@ -6507,6 +6506,7 @@
               <a:buNone/>
             </a:pPr>
             <a:r>
+              <a:rPr dirty="0"/>
               <a:t>Title</a:t>
             </a:r>
           </a:p>

</xml_diff>

<commit_message>
Updated README and reference.pptx
</commit_message>
<xml_diff>
--- a/src/processing/export/reference.pptx
+++ b/src/processing/export/reference.pptx
@@ -233,7 +233,7 @@
           <a:p>
             <a:fld id="{0F9C1CCF-B725-44A7-AA57-5E433BD85C9F}" type="datetimeFigureOut">
               <a:rPr lang="en-US" smtClean="0"/>
-              <a:t>4/24/2026</a:t>
+              <a:t>4/29/2026</a:t>
             </a:fld>
             <a:endParaRPr lang="en-US"/>
           </a:p>
@@ -1384,7 +1384,7 @@
           <a:p>
             <a:fld id="{2E51666C-3A23-4BEE-A9DB-51FB3AEBD618}" type="datetime1">
               <a:rPr lang="en-US" smtClean="0"/>
-              <a:t>4/24/2026</a:t>
+              <a:t>4/29/2026</a:t>
             </a:fld>
             <a:endParaRPr lang="en-US"/>
           </a:p>
@@ -1612,7 +1612,7 @@
           <a:p>
             <a:fld id="{604F1BEB-5272-46A8-9EF6-FEB649E31A1E}" type="datetime1">
               <a:rPr lang="en-US" smtClean="0"/>
-              <a:t>4/24/2026</a:t>
+              <a:t>4/29/2026</a:t>
             </a:fld>
             <a:endParaRPr lang="en-US"/>
           </a:p>
@@ -1926,7 +1926,7 @@
           <a:p>
             <a:fld id="{76FC36F1-61D3-4CC9-B4CE-3094973330D9}" type="datetime1">
               <a:rPr lang="en-US" smtClean="0"/>
-              <a:t>4/24/2026</a:t>
+              <a:t>4/29/2026</a:t>
             </a:fld>
             <a:endParaRPr lang="en-US"/>
           </a:p>
@@ -2267,7 +2267,7 @@
           <a:p>
             <a:fld id="{52C71740-C0E6-4B22-A0CB-CD2D939C625B}" type="datetime1">
               <a:rPr lang="en-US" smtClean="0"/>
-              <a:t>4/24/2026</a:t>
+              <a:t>4/29/2026</a:t>
             </a:fld>
             <a:endParaRPr lang="en-US"/>
           </a:p>
@@ -2581,7 +2581,7 @@
           <a:p>
             <a:fld id="{A71C5B13-D57F-42C6-9712-690861737014}" type="datetime1">
               <a:rPr lang="en-US" smtClean="0"/>
-              <a:t>4/24/2026</a:t>
+              <a:t>4/29/2026</a:t>
             </a:fld>
             <a:endParaRPr lang="en-US"/>
           </a:p>
@@ -2974,7 +2974,7 @@
           <a:p>
             <a:fld id="{70C9284D-C35A-487B-BF9E-DF7C5810A158}" type="datetime1">
               <a:rPr lang="en-US" smtClean="0"/>
-              <a:t>4/24/2026</a:t>
+              <a:t>4/29/2026</a:t>
             </a:fld>
             <a:endParaRPr lang="en-US"/>
           </a:p>
@@ -3144,7 +3144,7 @@
           <a:p>
             <a:fld id="{D99CC006-E0BD-4308-83FA-C33234346AFA}" type="datetime1">
               <a:rPr lang="en-US" smtClean="0"/>
-              <a:t>4/24/2026</a:t>
+              <a:t>4/29/2026</a:t>
             </a:fld>
             <a:endParaRPr lang="en-US"/>
           </a:p>
@@ -3324,7 +3324,7 @@
           <a:p>
             <a:fld id="{D8A3F75F-C647-4424-A5C6-3AD1DA0E4259}" type="datetime1">
               <a:rPr lang="en-US" smtClean="0"/>
-              <a:t>4/24/2026</a:t>
+              <a:t>4/29/2026</a:t>
             </a:fld>
             <a:endParaRPr lang="en-US"/>
           </a:p>
@@ -3424,10 +3424,9 @@
           </a:lstStyle>
           <a:p>
             <a:r>
-              <a:rPr lang="en-US"/>
+              <a:rPr lang="en-US" dirty="0"/>
               <a:t>Click to edit Master title style</a:t>
             </a:r>
-            <a:endParaRPr lang="en-US" dirty="0"/>
           </a:p>
         </p:txBody>
       </p:sp>
@@ -3505,7 +3504,7 @@
           <a:p>
             <a:fld id="{ED038B99-E455-48B4-9A06-BB731472B760}" type="datetime1">
               <a:rPr lang="en-US" smtClean="0"/>
-              <a:t>4/24/2026</a:t>
+              <a:t>4/29/2026</a:t>
             </a:fld>
             <a:endParaRPr lang="en-US"/>
           </a:p>
@@ -3779,7 +3778,7 @@
           <a:p>
             <a:fld id="{A966604E-E9A3-4667-B1ED-F3FC6ADD5085}" type="datetime1">
               <a:rPr lang="en-US" smtClean="0"/>
-              <a:t>4/24/2026</a:t>
+              <a:t>4/29/2026</a:t>
             </a:fld>
             <a:endParaRPr lang="en-US"/>
           </a:p>
@@ -4031,7 +4030,7 @@
           <a:p>
             <a:fld id="{2D6634CF-D376-4495-B0ED-111FD6B856DC}" type="datetime1">
               <a:rPr lang="en-US" smtClean="0"/>
-              <a:t>4/24/2026</a:t>
+              <a:t>4/29/2026</a:t>
             </a:fld>
             <a:endParaRPr lang="en-US"/>
           </a:p>
@@ -4414,7 +4413,7 @@
           <a:p>
             <a:fld id="{9F97D3DB-0F9E-4FB9-85FD-BA5D0659B991}" type="datetime1">
               <a:rPr lang="en-US" smtClean="0"/>
-              <a:t>4/24/2026</a:t>
+              <a:t>4/29/2026</a:t>
             </a:fld>
             <a:endParaRPr lang="en-US"/>
           </a:p>
@@ -4551,7 +4550,7 @@
           <a:p>
             <a:fld id="{90BDFFF4-5486-49D4-A995-BF5E4D4785EE}" type="datetime1">
               <a:rPr lang="en-US" smtClean="0"/>
-              <a:t>4/24/2026</a:t>
+              <a:t>4/29/2026</a:t>
             </a:fld>
             <a:endParaRPr lang="en-US"/>
           </a:p>
@@ -4646,7 +4645,7 @@
           <a:p>
             <a:fld id="{4AD9206C-0221-46B8-B929-86300A13CD64}" type="datetime1">
               <a:rPr lang="en-US" smtClean="0"/>
-              <a:t>4/24/2026</a:t>
+              <a:t>4/29/2026</a:t>
             </a:fld>
             <a:endParaRPr lang="en-US"/>
           </a:p>
@@ -4901,7 +4900,7 @@
           <a:p>
             <a:fld id="{E79D91DB-A863-412B-BDD9-CA5CB27997EC}" type="datetime1">
               <a:rPr lang="en-US" smtClean="0"/>
-              <a:t>4/24/2026</a:t>
+              <a:t>4/29/2026</a:t>
             </a:fld>
             <a:endParaRPr lang="en-US"/>
           </a:p>
@@ -5164,7 +5163,7 @@
           <a:p>
             <a:fld id="{6F8E4DCC-0F05-415C-9893-70EB0316C24F}" type="datetime1">
               <a:rPr lang="en-US" smtClean="0"/>
-              <a:t>4/24/2026</a:t>
+              <a:t>4/29/2026</a:t>
             </a:fld>
             <a:endParaRPr lang="en-US"/>
           </a:p>
@@ -5853,7 +5852,7 @@
           </a:prstGeom>
         </p:spPr>
         <p:txBody>
-          <a:bodyPr vert="horz" lIns="91440" tIns="45720" rIns="91440" bIns="45720" rtlCol="0" anchor="t">
+          <a:bodyPr vert="horz" lIns="91440" tIns="45720" rIns="91440" bIns="45720" rtlCol="0" anchor="b">
             <a:normAutofit/>
           </a:bodyPr>
           <a:lstStyle/>
@@ -5961,7 +5960,7 @@
           <a:p>
             <a:fld id="{FEBF4EA7-9EC7-4E89-B1A9-2CA1C48A054E}" type="datetime1">
               <a:rPr lang="en-US" smtClean="0"/>
-              <a:t>4/24/2026</a:t>
+              <a:t>4/29/2026</a:t>
             </a:fld>
             <a:endParaRPr lang="en-US"/>
           </a:p>

</xml_diff>